<commit_message>
Updated Poster and Poster Qmd
</commit_message>
<xml_diff>
--- a/MichiganPFAS_ResearchPoster.pptx
+++ b/MichiganPFAS_ResearchPoster.pptx
@@ -257,7 +257,7 @@
       </p15:sldGuideLst>
     </p:ext>
     <p:ext uri="http://customooxmlschemas.google.com/">
-      <go:slidesCustomData xmlns:go="http://customooxmlschemas.google.com/" xmlns:ahyp="http://schemas.microsoft.com/office/drawing/2018/hyperlinkcolor" xmlns:p15="http://schemas.microsoft.com/office/powerpoint/2012/main" xmlns:p14="http://schemas.microsoft.com/office/powerpoint/2010/main" xmlns:com="http://schemas.openxmlformats.org/drawingml/2006/compatibility" xmlns:pvml="urn:schemas-microsoft-com:office:powerpoint" xmlns:v="urn:schemas-microsoft-com:vml" xmlns:o="urn:schemas-microsoft-com:office:office" xmlns:dgm="http://schemas.openxmlformats.org/drawingml/2006/diagram" xmlns:c="http://schemas.openxmlformats.org/drawingml/2006/chart" xmlns:mv="urn:schemas-microsoft-com:mac:vml" xmlns:mc="http://schemas.openxmlformats.org/markup-compatibility/2006" xmlns="" r:id="rId9" roundtripDataSignature="AMtx7mi8fLYElh59t4jHQwYsQUndL0Eu8g=="/>
+      <go:slidesCustomData xmlns="" xmlns:mc="http://schemas.openxmlformats.org/markup-compatibility/2006" xmlns:mv="urn:schemas-microsoft-com:mac:vml" xmlns:c="http://schemas.openxmlformats.org/drawingml/2006/chart" xmlns:dgm="http://schemas.openxmlformats.org/drawingml/2006/diagram" xmlns:o="urn:schemas-microsoft-com:office:office" xmlns:v="urn:schemas-microsoft-com:vml" xmlns:pvml="urn:schemas-microsoft-com:office:powerpoint" xmlns:com="http://schemas.openxmlformats.org/drawingml/2006/compatibility" xmlns:p14="http://schemas.microsoft.com/office/powerpoint/2010/main" xmlns:p15="http://schemas.microsoft.com/office/powerpoint/2012/main" xmlns:ahyp="http://schemas.microsoft.com/office/drawing/2018/hyperlinkcolor" xmlns:go="http://customooxmlschemas.google.com/" r:id="rId9" roundtripDataSignature="AMtx7mi8fLYElh59t4jHQwYsQUndL0Eu8g=="/>
     </p:ext>
   </p:extLst>
 </p:presentation>
@@ -266,7 +266,7 @@
 <file path=ppt/revisionInfo.xml><?xml version="1.0" encoding="utf-8"?>
 <p1510:revInfo xmlns:a="http://schemas.openxmlformats.org/drawingml/2006/main" xmlns:r="http://schemas.openxmlformats.org/officeDocument/2006/relationships" xmlns:p1510="http://schemas.microsoft.com/office/powerpoint/2015/10/main">
   <p1510:revLst>
-    <p1510:client id="{6C20A5EC-8840-9940-BC91-4086AF4B13F5}" v="336" dt="2026-03-24T04:33:06.714"/>
+    <p1510:client id="{6C20A5EC-8840-9940-BC91-4086AF4B13F5}" v="33" dt="2026-03-25T11:29:17.515"/>
   </p1510:revLst>
 </p1510:revInfo>
 </file>
@@ -276,18 +276,18 @@
   <pc:docChgLst>
     <pc:chgData name="Nancy A. Odhiambo" userId="9fd03ea9-f642-46ed-82e0-72dc91a725bc" providerId="ADAL" clId="{6B025E33-D5BB-5DD4-954E-4AC3FAD535B9}"/>
     <pc:docChg chg="undo custSel modSld">
-      <pc:chgData name="Nancy A. Odhiambo" userId="9fd03ea9-f642-46ed-82e0-72dc91a725bc" providerId="ADAL" clId="{6B025E33-D5BB-5DD4-954E-4AC3FAD535B9}" dt="2026-03-24T04:35:00.185" v="1968" actId="20577"/>
+      <pc:chgData name="Nancy A. Odhiambo" userId="9fd03ea9-f642-46ed-82e0-72dc91a725bc" providerId="ADAL" clId="{6B025E33-D5BB-5DD4-954E-4AC3FAD535B9}" dt="2026-03-25T11:29:17.515" v="2034" actId="255"/>
       <pc:docMkLst>
         <pc:docMk/>
       </pc:docMkLst>
       <pc:sldChg chg="addSp delSp modSp mod">
-        <pc:chgData name="Nancy A. Odhiambo" userId="9fd03ea9-f642-46ed-82e0-72dc91a725bc" providerId="ADAL" clId="{6B025E33-D5BB-5DD4-954E-4AC3FAD535B9}" dt="2026-03-24T04:35:00.185" v="1968" actId="20577"/>
+        <pc:chgData name="Nancy A. Odhiambo" userId="9fd03ea9-f642-46ed-82e0-72dc91a725bc" providerId="ADAL" clId="{6B025E33-D5BB-5DD4-954E-4AC3FAD535B9}" dt="2026-03-25T11:29:17.515" v="2034" actId="255"/>
         <pc:sldMkLst>
           <pc:docMk/>
           <pc:sldMk cId="3865402343" sldId="261"/>
         </pc:sldMkLst>
         <pc:spChg chg="add del mod">
-          <ac:chgData name="Nancy A. Odhiambo" userId="9fd03ea9-f642-46ed-82e0-72dc91a725bc" providerId="ADAL" clId="{6B025E33-D5BB-5DD4-954E-4AC3FAD535B9}" dt="2026-03-24T04:27:57.340" v="1938" actId="20577"/>
+          <ac:chgData name="Nancy A. Odhiambo" userId="9fd03ea9-f642-46ed-82e0-72dc91a725bc" providerId="ADAL" clId="{6B025E33-D5BB-5DD4-954E-4AC3FAD535B9}" dt="2026-03-25T11:29:17.515" v="2034" actId="255"/>
           <ac:spMkLst>
             <pc:docMk/>
             <pc:sldMk cId="3865402343" sldId="261"/>
@@ -367,19 +367,51 @@
           </ac:spMkLst>
         </pc:spChg>
         <pc:spChg chg="add del mod">
-          <ac:chgData name="Nancy A. Odhiambo" userId="9fd03ea9-f642-46ed-82e0-72dc91a725bc" providerId="ADAL" clId="{6B025E33-D5BB-5DD4-954E-4AC3FAD535B9}" dt="2026-03-24T04:35:00.185" v="1968" actId="20577"/>
+          <ac:chgData name="Nancy A. Odhiambo" userId="9fd03ea9-f642-46ed-82e0-72dc91a725bc" providerId="ADAL" clId="{6B025E33-D5BB-5DD4-954E-4AC3FAD535B9}" dt="2026-03-25T11:24:12.261" v="2008" actId="14100"/>
           <ac:spMkLst>
             <pc:docMk/>
             <pc:sldMk cId="3865402343" sldId="261"/>
             <ac:spMk id="50" creationId="{AB71F360-BB8B-D375-3180-E5F2E2514D50}"/>
           </ac:spMkLst>
         </pc:spChg>
+        <pc:picChg chg="add mod">
+          <ac:chgData name="Nancy A. Odhiambo" userId="9fd03ea9-f642-46ed-82e0-72dc91a725bc" providerId="ADAL" clId="{6B025E33-D5BB-5DD4-954E-4AC3FAD535B9}" dt="2026-03-25T11:08:20.240" v="1998" actId="14100"/>
+          <ac:picMkLst>
+            <pc:docMk/>
+            <pc:sldMk cId="3865402343" sldId="261"/>
+            <ac:picMk id="4" creationId="{2275A505-4BB7-0C64-4386-A57A3D5AAC1E}"/>
+          </ac:picMkLst>
+        </pc:picChg>
+        <pc:picChg chg="add mod">
+          <ac:chgData name="Nancy A. Odhiambo" userId="9fd03ea9-f642-46ed-82e0-72dc91a725bc" providerId="ADAL" clId="{6B025E33-D5BB-5DD4-954E-4AC3FAD535B9}" dt="2026-03-25T11:08:52.323" v="2001" actId="14100"/>
+          <ac:picMkLst>
+            <pc:docMk/>
+            <pc:sldMk cId="3865402343" sldId="261"/>
+            <ac:picMk id="7" creationId="{8DB399D0-5D23-D139-707D-865B3CB825B9}"/>
+          </ac:picMkLst>
+        </pc:picChg>
         <pc:picChg chg="add del mod">
           <ac:chgData name="Nancy A. Odhiambo" userId="9fd03ea9-f642-46ed-82e0-72dc91a725bc" providerId="ADAL" clId="{6B025E33-D5BB-5DD4-954E-4AC3FAD535B9}" dt="2026-03-24T04:08:44.616" v="1644" actId="478"/>
           <ac:picMkLst>
             <pc:docMk/>
             <pc:sldMk cId="3865402343" sldId="261"/>
             <ac:picMk id="11" creationId="{BB728658-9F61-908A-3DCE-2DBBF3565C05}"/>
+          </ac:picMkLst>
+        </pc:picChg>
+        <pc:picChg chg="add mod">
+          <ac:chgData name="Nancy A. Odhiambo" userId="9fd03ea9-f642-46ed-82e0-72dc91a725bc" providerId="ADAL" clId="{6B025E33-D5BB-5DD4-954E-4AC3FAD535B9}" dt="2026-03-25T11:06:58.889" v="1995" actId="14100"/>
+          <ac:picMkLst>
+            <pc:docMk/>
+            <pc:sldMk cId="3865402343" sldId="261"/>
+            <ac:picMk id="12" creationId="{04858FAE-1C8D-0946-B8C3-06B7A8DBCB97}"/>
+          </ac:picMkLst>
+        </pc:picChg>
+        <pc:picChg chg="add mod">
+          <ac:chgData name="Nancy A. Odhiambo" userId="9fd03ea9-f642-46ed-82e0-72dc91a725bc" providerId="ADAL" clId="{6B025E33-D5BB-5DD4-954E-4AC3FAD535B9}" dt="2026-03-25T11:23:58.160" v="2007" actId="14100"/>
+          <ac:picMkLst>
+            <pc:docMk/>
+            <pc:sldMk cId="3865402343" sldId="261"/>
+            <ac:picMk id="14" creationId="{B5BA9DBB-2550-B185-75A1-8A4A4386A3B4}"/>
           </ac:picMkLst>
         </pc:picChg>
       </pc:sldChg>
@@ -7282,6 +7314,36 @@
                     <a:spcPct val="95833"/>
                   </a:lnSpc>
                 </a:pPr>
+                <a14:m>
+                  <m:oMathPara xmlns:m="http://schemas.openxmlformats.org/officeDocument/2006/math">
+                    <m:oMathParaPr>
+                      <m:jc m:val="centerGroup"/>
+                    </m:oMathParaPr>
+                    <m:oMath xmlns:m="http://schemas.openxmlformats.org/officeDocument/2006/math">
+                      <a:fld id="{825F15A7-03F4-43D7-82C5-3E23DA2F108C}" type="mathplaceholder">
+                        <a:rPr lang="en-US" sz="4800" b="1" i="1" smtClean="0">
+                          <a:solidFill>
+                            <a:srgbClr val="005BBB"/>
+                          </a:solidFill>
+                          <a:latin typeface="Cambria Math" panose="02040503050406030204" pitchFamily="18" charset="0"/>
+                        </a:rPr>
+                        <a:t>Type equation here.</a:t>
+                      </a:fld>
+                    </m:oMath>
+                  </m:oMathPara>
+                </a14:m>
+                <a:endParaRPr lang="en-US" sz="4800" b="1" dirty="0">
+                  <a:solidFill>
+                    <a:srgbClr val="005BBB"/>
+                  </a:solidFill>
+                </a:endParaRPr>
+              </a:p>
+              <a:p>
+                <a:pPr marL="0" lvl="0" indent="0">
+                  <a:lnSpc>
+                    <a:spcPct val="95833"/>
+                  </a:lnSpc>
+                </a:pPr>
                 <a:endParaRPr lang="en-US" sz="3200" dirty="0">
                   <a:solidFill>
                     <a:srgbClr val="666666">
@@ -7294,7 +7356,7 @@
                 <a14:m>
                   <m:oMath xmlns:m="http://schemas.openxmlformats.org/officeDocument/2006/math">
                     <m:r>
-                      <a:rPr lang="en-US" sz="3200" b="1" i="1" smtClean="0">
+                      <a:rPr lang="en-US" b="1" i="1" smtClean="0">
                         <a:solidFill>
                           <a:schemeClr val="accent1">
                             <a:lumMod val="50000"/>
@@ -7305,7 +7367,7 @@
                       <m:t>𝑯𝑰</m:t>
                     </m:r>
                     <m:r>
-                      <a:rPr lang="en-US" sz="3200" b="1" i="1" smtClean="0">
+                      <a:rPr lang="en-US" b="1" i="1" smtClean="0">
                         <a:solidFill>
                           <a:schemeClr val="accent1">
                             <a:lumMod val="50000"/>
@@ -7318,7 +7380,7 @@
                     <m:d>
                       <m:dPr>
                         <m:ctrlPr>
-                          <a:rPr lang="en-US" sz="3200" b="1" i="1" smtClean="0">
+                          <a:rPr lang="en-US" b="1" i="1" smtClean="0">
                             <a:solidFill>
                               <a:schemeClr val="accent1">
                                 <a:lumMod val="50000"/>
@@ -7330,7 +7392,7 @@
                       </m:dPr>
                       <m:e>
                         <m:r>
-                          <a:rPr lang="en-US" sz="3200" b="1" i="1" smtClean="0">
+                          <a:rPr lang="en-US" b="1" i="1" smtClean="0">
                             <a:solidFill>
                               <a:schemeClr val="accent1">
                                 <a:lumMod val="50000"/>
@@ -7343,7 +7405,7 @@
                       </m:e>
                     </m:d>
                     <m:r>
-                      <a:rPr lang="en-US" sz="3200" b="1" i="1" smtClean="0">
+                      <a:rPr lang="en-US" b="1" i="1" smtClean="0">
                         <a:solidFill>
                           <a:schemeClr val="accent1">
                             <a:lumMod val="50000"/>
@@ -7354,7 +7416,7 @@
                       <m:t>=(</m:t>
                     </m:r>
                     <m:r>
-                      <a:rPr lang="en-US" sz="3200" b="1" i="1" smtClean="0">
+                      <a:rPr lang="en-US" b="1" i="1" smtClean="0">
                         <a:solidFill>
                           <a:schemeClr val="accent1">
                             <a:lumMod val="50000"/>
@@ -7365,7 +7427,7 @@
                       <m:t>𝑯𝑭𝑷𝑶</m:t>
                     </m:r>
                     <m:r>
-                      <a:rPr lang="en-US" sz="3200" b="1" i="1" smtClean="0">
+                      <a:rPr lang="en-US" b="1" i="1" smtClean="0">
                         <a:solidFill>
                           <a:schemeClr val="accent1">
                             <a:lumMod val="50000"/>
@@ -7376,7 +7438,7 @@
                       <m:t>−</m:t>
                     </m:r>
                     <m:r>
-                      <a:rPr lang="en-US" sz="3200" b="1" i="1" smtClean="0">
+                      <a:rPr lang="en-US" b="1" i="1" smtClean="0">
                         <a:solidFill>
                           <a:schemeClr val="accent1">
                             <a:lumMod val="50000"/>
@@ -7389,7 +7451,7 @@
                     <m:d>
                       <m:dPr>
                         <m:ctrlPr>
-                          <a:rPr lang="en-US" sz="3200" b="1" i="1" smtClean="0">
+                          <a:rPr lang="en-US" b="1" i="1" smtClean="0">
                             <a:solidFill>
                               <a:schemeClr val="accent1">
                                 <a:lumMod val="50000"/>
@@ -7401,7 +7463,7 @@
                       </m:dPr>
                       <m:e>
                         <m:r>
-                          <a:rPr lang="en-US" sz="3200" b="1" i="1" smtClean="0">
+                          <a:rPr lang="en-US" b="1" i="1" smtClean="0">
                             <a:solidFill>
                               <a:schemeClr val="accent1">
                                 <a:lumMod val="50000"/>
@@ -7414,7 +7476,7 @@
                       </m:e>
                     </m:d>
                     <m:r>
-                      <a:rPr lang="en-US" sz="3200" b="1" i="1" smtClean="0">
+                      <a:rPr lang="en-US" b="1" i="1" smtClean="0">
                         <a:solidFill>
                           <a:schemeClr val="accent1">
                             <a:lumMod val="50000"/>
@@ -7425,7 +7487,7 @@
                       <m:t>/</m:t>
                     </m:r>
                     <m:r>
-                      <a:rPr lang="en-US" sz="3200" b="1" i="1" smtClean="0">
+                      <a:rPr lang="en-US" b="1" i="1" smtClean="0">
                         <a:solidFill>
                           <a:schemeClr val="accent1">
                             <a:lumMod val="50000"/>
@@ -7438,7 +7500,7 @@
                   </m:oMath>
                 </a14:m>
                 <a:r>
-                  <a:rPr lang="en-US" sz="3200" b="1" dirty="0">
+                  <a:rPr lang="en-US" b="1" dirty="0">
                     <a:solidFill>
                       <a:schemeClr val="accent1">
                         <a:lumMod val="50000"/>
@@ -7450,7 +7512,7 @@
                 <a14:m>
                   <m:oMath xmlns:m="http://schemas.openxmlformats.org/officeDocument/2006/math">
                     <m:r>
-                      <a:rPr lang="en-US" sz="3200" b="1" i="1">
+                      <a:rPr lang="en-US" b="1" i="1">
                         <a:solidFill>
                           <a:schemeClr val="accent1">
                             <a:lumMod val="50000"/>
@@ -7461,7 +7523,7 @@
                       <m:t>(</m:t>
                     </m:r>
                     <m:r>
-                      <a:rPr lang="en-US" sz="3200" b="1" i="1" smtClean="0">
+                      <a:rPr lang="en-US" b="1" i="1" smtClean="0">
                         <a:solidFill>
                           <a:schemeClr val="accent1">
                             <a:lumMod val="50000"/>
@@ -7474,7 +7536,7 @@
                     <m:d>
                       <m:dPr>
                         <m:ctrlPr>
-                          <a:rPr lang="en-US" sz="3200" b="1" i="1">
+                          <a:rPr lang="en-US" b="1" i="1">
                             <a:solidFill>
                               <a:schemeClr val="accent1">
                                 <a:lumMod val="50000"/>
@@ -7486,7 +7548,7 @@
                       </m:dPr>
                       <m:e>
                         <m:r>
-                          <a:rPr lang="en-US" sz="3200" b="1" i="1">
+                          <a:rPr lang="en-US" b="1" i="1">
                             <a:solidFill>
                               <a:schemeClr val="accent1">
                                 <a:lumMod val="50000"/>
@@ -7499,7 +7561,7 @@
                       </m:e>
                     </m:d>
                     <m:r>
-                      <a:rPr lang="en-US" sz="3200" b="1" i="1">
+                      <a:rPr lang="en-US" b="1" i="1">
                         <a:solidFill>
                           <a:schemeClr val="accent1">
                             <a:lumMod val="50000"/>
@@ -7510,7 +7572,7 @@
                       <m:t>/</m:t>
                     </m:r>
                     <m:r>
-                      <a:rPr lang="en-US" sz="3200" b="1" i="1" smtClean="0">
+                      <a:rPr lang="en-US" b="1" i="1" smtClean="0">
                         <a:solidFill>
                           <a:schemeClr val="accent1">
                             <a:lumMod val="50000"/>
@@ -7521,7 +7583,7 @@
                       <m:t>𝟐𝟎𝟎</m:t>
                     </m:r>
                     <m:r>
-                      <a:rPr lang="en-US" sz="3200" b="1" i="1">
+                      <a:rPr lang="en-US" b="1" i="1">
                         <a:solidFill>
                           <a:schemeClr val="accent1">
                             <a:lumMod val="50000"/>
@@ -7534,7 +7596,7 @@
                   </m:oMath>
                 </a14:m>
                 <a:r>
-                  <a:rPr lang="en-US" sz="3200" b="1" dirty="0">
+                  <a:rPr lang="en-US" b="1" dirty="0">
                     <a:solidFill>
                       <a:schemeClr val="accent1">
                         <a:lumMod val="50000"/>
@@ -7546,7 +7608,7 @@
                 <a14:m>
                   <m:oMath xmlns:m="http://schemas.openxmlformats.org/officeDocument/2006/math">
                     <m:r>
-                      <a:rPr lang="en-US" sz="3200" b="1" i="1">
+                      <a:rPr lang="en-US" b="1" i="1">
                         <a:solidFill>
                           <a:schemeClr val="accent1">
                             <a:lumMod val="50000"/>
@@ -7557,7 +7619,7 @@
                       <m:t>(</m:t>
                     </m:r>
                     <m:r>
-                      <a:rPr lang="en-US" sz="3200" b="1" i="1" smtClean="0">
+                      <a:rPr lang="en-US" b="1" i="1" smtClean="0">
                         <a:solidFill>
                           <a:schemeClr val="accent1">
                             <a:lumMod val="50000"/>
@@ -7570,7 +7632,7 @@
                     <m:d>
                       <m:dPr>
                         <m:ctrlPr>
-                          <a:rPr lang="en-US" sz="3200" b="1" i="1">
+                          <a:rPr lang="en-US" b="1" i="1">
                             <a:solidFill>
                               <a:schemeClr val="accent1">
                                 <a:lumMod val="50000"/>
@@ -7582,7 +7644,7 @@
                       </m:dPr>
                       <m:e>
                         <m:r>
-                          <a:rPr lang="en-US" sz="3200" b="1" i="1">
+                          <a:rPr lang="en-US" b="1" i="1">
                             <a:solidFill>
                               <a:schemeClr val="accent1">
                                 <a:lumMod val="50000"/>
@@ -7595,7 +7657,7 @@
                       </m:e>
                     </m:d>
                     <m:r>
-                      <a:rPr lang="en-US" sz="3200" b="1" i="1">
+                      <a:rPr lang="en-US" b="1" i="1">
                         <a:solidFill>
                           <a:schemeClr val="accent1">
                             <a:lumMod val="50000"/>
@@ -7606,7 +7668,7 @@
                       <m:t>/</m:t>
                     </m:r>
                     <m:r>
-                      <a:rPr lang="en-US" sz="3200" b="1" i="1">
+                      <a:rPr lang="en-US" b="1" i="1">
                         <a:solidFill>
                           <a:schemeClr val="accent1">
                             <a:lumMod val="50000"/>
@@ -7619,7 +7681,7 @@
                   </m:oMath>
                 </a14:m>
                 <a:r>
-                  <a:rPr lang="en-US" sz="3200" b="1" dirty="0">
+                  <a:rPr lang="en-US" b="1" dirty="0">
                     <a:solidFill>
                       <a:schemeClr val="accent1">
                         <a:lumMod val="50000"/>
@@ -7631,7 +7693,7 @@
                 <a14:m>
                   <m:oMath xmlns:m="http://schemas.openxmlformats.org/officeDocument/2006/math">
                     <m:r>
-                      <a:rPr lang="en-US" sz="3200" b="1" i="1">
+                      <a:rPr lang="en-US" b="1" i="1">
                         <a:solidFill>
                           <a:schemeClr val="accent1">
                             <a:lumMod val="50000"/>
@@ -7642,7 +7704,7 @@
                       <m:t>(</m:t>
                     </m:r>
                     <m:r>
-                      <a:rPr lang="en-US" sz="3200" b="1" i="1" smtClean="0">
+                      <a:rPr lang="en-US" b="1" i="1" smtClean="0">
                         <a:solidFill>
                           <a:schemeClr val="accent1">
                             <a:lumMod val="50000"/>
@@ -7653,7 +7715,7 @@
                       <m:t>𝑷𝑭𝑯𝒙𝑺</m:t>
                     </m:r>
                     <m:r>
-                      <a:rPr lang="en-US" sz="3200" b="1" i="1">
+                      <a:rPr lang="en-US" b="1" i="1">
                         <a:solidFill>
                           <a:schemeClr val="accent1">
                             <a:lumMod val="50000"/>
@@ -7664,7 +7726,7 @@
                       <m:t>/</m:t>
                     </m:r>
                     <m:r>
-                      <a:rPr lang="en-US" sz="3200" b="1" i="1">
+                      <a:rPr lang="en-US" b="1" i="1">
                         <a:solidFill>
                           <a:schemeClr val="accent1">
                             <a:lumMod val="50000"/>
@@ -7677,7 +7739,7 @@
                   </m:oMath>
                 </a14:m>
                 <a:r>
-                  <a:rPr lang="en-US" sz="3200" b="1" dirty="0">
+                  <a:rPr lang="en-US" b="1" dirty="0">
                     <a:solidFill>
                       <a:schemeClr val="accent1">
                         <a:lumMod val="50000"/>
@@ -7767,7 +7829,7 @@
               <a:blipFill>
                 <a:blip r:embed="rId2"/>
                 <a:stretch>
-                  <a:fillRect l="-1997" t="-716" r="-1649"/>
+                  <a:fillRect l="-1997" t="-716" r="-1649" b="-256"/>
                 </a:stretch>
               </a:blipFill>
             </p:spPr>
@@ -8305,8 +8367,8 @@
         </p:nvSpPr>
         <p:spPr>
           <a:xfrm>
-            <a:off x="28996106" y="5619555"/>
-            <a:ext cx="14895094" cy="24812177"/>
+            <a:off x="29260800" y="5619555"/>
+            <a:ext cx="14630400" cy="24812177"/>
           </a:xfrm>
         </p:spPr>
         <p:txBody>
@@ -9006,6 +9068,126 @@
           </a:p>
         </p:txBody>
       </p:sp>
+      <p:pic>
+        <p:nvPicPr>
+          <p:cNvPr id="4" name="Picture 3">
+            <a:extLst>
+              <a:ext uri="{FF2B5EF4-FFF2-40B4-BE49-F238E27FC236}">
+                <a16:creationId xmlns:a16="http://schemas.microsoft.com/office/drawing/2014/main" id="{2275A505-4BB7-0C64-4386-A57A3D5AAC1E}"/>
+              </a:ext>
+            </a:extLst>
+          </p:cNvPr>
+          <p:cNvPicPr>
+            <a:picLocks noChangeAspect="1"/>
+          </p:cNvPicPr>
+          <p:nvPr/>
+        </p:nvPicPr>
+        <p:blipFill>
+          <a:blip r:embed="rId10"/>
+          <a:stretch>
+            <a:fillRect/>
+          </a:stretch>
+        </p:blipFill>
+        <p:spPr>
+          <a:xfrm>
+            <a:off x="14951033" y="6614556"/>
+            <a:ext cx="12365181" cy="8243454"/>
+          </a:xfrm>
+          <a:prstGeom prst="rect">
+            <a:avLst/>
+          </a:prstGeom>
+        </p:spPr>
+      </p:pic>
+      <p:pic>
+        <p:nvPicPr>
+          <p:cNvPr id="7" name="Picture 6">
+            <a:extLst>
+              <a:ext uri="{FF2B5EF4-FFF2-40B4-BE49-F238E27FC236}">
+                <a16:creationId xmlns:a16="http://schemas.microsoft.com/office/drawing/2014/main" id="{8DB399D0-5D23-D139-707D-865B3CB825B9}"/>
+              </a:ext>
+            </a:extLst>
+          </p:cNvPr>
+          <p:cNvPicPr>
+            <a:picLocks noChangeAspect="1"/>
+          </p:cNvPicPr>
+          <p:nvPr/>
+        </p:nvPicPr>
+        <p:blipFill>
+          <a:blip r:embed="rId11"/>
+          <a:stretch>
+            <a:fillRect/>
+          </a:stretch>
+        </p:blipFill>
+        <p:spPr>
+          <a:xfrm>
+            <a:off x="14065131" y="15267285"/>
+            <a:ext cx="12670183" cy="9050129"/>
+          </a:xfrm>
+          <a:prstGeom prst="rect">
+            <a:avLst/>
+          </a:prstGeom>
+        </p:spPr>
+      </p:pic>
+      <p:pic>
+        <p:nvPicPr>
+          <p:cNvPr id="12" name="Picture 11">
+            <a:extLst>
+              <a:ext uri="{FF2B5EF4-FFF2-40B4-BE49-F238E27FC236}">
+                <a16:creationId xmlns:a16="http://schemas.microsoft.com/office/drawing/2014/main" id="{04858FAE-1C8D-0946-B8C3-06B7A8DBCB97}"/>
+              </a:ext>
+            </a:extLst>
+          </p:cNvPr>
+          <p:cNvPicPr>
+            <a:picLocks noChangeAspect="1"/>
+          </p:cNvPicPr>
+          <p:nvPr/>
+        </p:nvPicPr>
+        <p:blipFill>
+          <a:blip r:embed="rId12"/>
+          <a:stretch>
+            <a:fillRect/>
+          </a:stretch>
+        </p:blipFill>
+        <p:spPr>
+          <a:xfrm>
+            <a:off x="29812065" y="5707504"/>
+            <a:ext cx="13383695" cy="9559782"/>
+          </a:xfrm>
+          <a:prstGeom prst="rect">
+            <a:avLst/>
+          </a:prstGeom>
+        </p:spPr>
+      </p:pic>
+      <p:pic>
+        <p:nvPicPr>
+          <p:cNvPr id="14" name="Picture 13">
+            <a:extLst>
+              <a:ext uri="{FF2B5EF4-FFF2-40B4-BE49-F238E27FC236}">
+                <a16:creationId xmlns:a16="http://schemas.microsoft.com/office/drawing/2014/main" id="{B5BA9DBB-2550-B185-75A1-8A4A4386A3B4}"/>
+              </a:ext>
+            </a:extLst>
+          </p:cNvPr>
+          <p:cNvPicPr>
+            <a:picLocks noChangeAspect="1"/>
+          </p:cNvPicPr>
+          <p:nvPr/>
+        </p:nvPicPr>
+        <p:blipFill>
+          <a:blip r:embed="rId13"/>
+          <a:stretch>
+            <a:fillRect/>
+          </a:stretch>
+        </p:blipFill>
+        <p:spPr>
+          <a:xfrm>
+            <a:off x="15179475" y="24561462"/>
+            <a:ext cx="13816630" cy="5526652"/>
+          </a:xfrm>
+          <a:prstGeom prst="rect">
+            <a:avLst/>
+          </a:prstGeom>
+        </p:spPr>
+      </p:pic>
     </p:spTree>
     <p:extLst>
       <p:ext uri="{BB962C8B-B14F-4D97-AF65-F5344CB8AC3E}">

</xml_diff>